<commit_message>
Explica que es SUS en el README, el protocolo y la presentacion
El README nombraba SUS en los objetivos, los entregables y la rubrica sin
decir que es. Ahora el modulo 5 lo define en una linea y enlaza a la seccion
del protocolo. El protocolo agrega que mide (lo percibido, frente a lo hecho),
su origen (John Brooke, 1986) y por que no se deben cambiar las afirmaciones.
La diapositiva 17 incluye la definicion y dos afirmaciones reales.

Co-Authored-By: Claude Opus 5 <noreply@anthropic.com>
</commit_message>
<xml_diff>
--- a/Pruebas de UI y UX.pptx
+++ b/Pruebas de UI y UX.pptx
@@ -1355,7 +1355,7 @@
           <a:lstStyle/>
           <a:p>
             <a:r>
-              <a:t>Diez preguntas al terminar la sesión, de 1 a 5. Las impares suman x - 1, las pares 5 - x, y la suma se multiplica por 2,5. El resultado va de 0 a 100 y no es un porcentaje. 68 es la media de la industria: la mitad de los sistemas medidos puntúan por debajo. Bandas de Sauro y Lewis.</a:t>
+              <a:t>SUS, System Usability Scale: un cuestionario estándar creado por John Brooke en 1986. Las otras métricas registran lo que la persona hizo; SUS mide lo que percibió. Como es estándar, permite comparar con otros sistemas, siempre que no se cambien las afirmaciones. Se alternan positivas (impares) y negativas (pares) para que nadie responda 5 a todo sin leer. Diez preguntas al terminar la sesión, de 1 a 5. Las impares suman x - 1, las pares 5 - x, y la suma se multiplica por 2,5. El resultado va de 0 a 100 y no es un porcentaje. 68 es la media de la industria: la mitad de los sistemas medidos puntúan por debajo. Bandas de Sauro y Lewis.</a:t>
             </a:r>
           </a:p>
         </p:txBody>
@@ -13940,13 +13940,143 @@
       </p:sp>
       <p:sp>
         <p:nvSpPr>
-          <p:cNvPr id="6" name="TextBox 5"/>
-          <p:cNvSpPr txBox="1"/>
-          <p:nvPr/>
-        </p:nvSpPr>
-        <p:spPr>
-          <a:xfrm>
-            <a:off x="548640" y="1600200"/>
+          <p:cNvPr id="6" name="Rounded Rectangle 5"/>
+          <p:cNvSpPr/>
+          <p:nvPr/>
+        </p:nvSpPr>
+        <p:spPr>
+          <a:xfrm>
+            <a:off x="548640" y="1463040"/>
+            <a:ext cx="11109960" cy="868680"/>
+          </a:xfrm>
+          <a:prstGeom prst="roundRect">
+            <a:avLst>
+              <a:gd name="adj" fmla="val 5000"/>
+            </a:avLst>
+          </a:prstGeom>
+          <a:solidFill>
+            <a:srgbClr val="FBE1D6"/>
+          </a:solidFill>
+          <a:ln>
+            <a:noFill/>
+          </a:ln>
+          <a:effectLst/>
+        </p:spPr>
+        <p:style>
+          <a:lnRef idx="1">
+            <a:schemeClr val="accent1"/>
+          </a:lnRef>
+          <a:fillRef idx="3">
+            <a:schemeClr val="accent1"/>
+          </a:fillRef>
+          <a:effectRef idx="2">
+            <a:schemeClr val="accent1"/>
+          </a:effectRef>
+          <a:fontRef idx="minor">
+            <a:schemeClr val="lt1"/>
+          </a:fontRef>
+        </p:style>
+        <p:txBody>
+          <a:bodyPr rtlCol="0" anchor="ctr" lIns="109728" rIns="109728"/>
+          <a:lstStyle/>
+          <a:p>
+            <a:pPr algn="ctr"/>
+          </a:p>
+        </p:txBody>
+      </p:sp>
+      <p:sp>
+        <p:nvSpPr>
+          <p:cNvPr id="7" name="TextBox 6"/>
+          <p:cNvSpPr txBox="1"/>
+          <p:nvPr/>
+        </p:nvSpPr>
+        <p:spPr>
+          <a:xfrm>
+            <a:off x="777240" y="1572768"/>
+            <a:ext cx="10698480" cy="685800"/>
+          </a:xfrm>
+          <a:prstGeom prst="rect">
+            <a:avLst/>
+          </a:prstGeom>
+          <a:noFill/>
+        </p:spPr>
+        <p:txBody>
+          <a:bodyPr wrap="square" lIns="0" rIns="0" tIns="0" bIns="0" anchor="t">
+            <a:spAutoFit/>
+          </a:bodyPr>
+          <a:lstStyle/>
+          <a:p>
+            <a:pPr algn="l">
+              <a:lnSpc>
+                <a:spcPct val="115000"/>
+              </a:lnSpc>
+            </a:pPr>
+            <a:r>
+              <a:rPr sz="1300" b="1" i="0">
+                <a:solidFill>
+                  <a:srgbClr val="EB6834"/>
+                </a:solidFill>
+                <a:latin typeface="Segoe UI"/>
+              </a:rPr>
+              <a:t>SUS (System Usability Scale): </a:t>
+            </a:r>
+            <a:r>
+              <a:rPr sz="1300" b="0" i="0">
+                <a:solidFill>
+                  <a:srgbClr val="52514E"/>
+                </a:solidFill>
+                <a:latin typeface="Segoe UI"/>
+              </a:rPr>
+              <a:t>10 afirmaciones estándar que cada participante califica de 1 a 5 al terminar. Mide la usabilidad que la persona percibió, no lo que hizo. Se alternan: </a:t>
+            </a:r>
+            <a:r>
+              <a:rPr sz="1300" b="0" i="1">
+                <a:solidFill>
+                  <a:srgbClr val="0B0B0B"/>
+                </a:solidFill>
+                <a:latin typeface="Segoe UI"/>
+              </a:rPr>
+              <a:t>"Pensé que el sistema era fácil de usar"</a:t>
+            </a:r>
+            <a:r>
+              <a:rPr sz="1300" b="0" i="0">
+                <a:solidFill>
+                  <a:srgbClr val="52514E"/>
+                </a:solidFill>
+                <a:latin typeface="Segoe UI"/>
+              </a:rPr>
+              <a:t> (impar, positiva) y </a:t>
+            </a:r>
+            <a:r>
+              <a:rPr sz="1300" b="0" i="1">
+                <a:solidFill>
+                  <a:srgbClr val="0B0B0B"/>
+                </a:solidFill>
+                <a:latin typeface="Segoe UI"/>
+              </a:rPr>
+              <a:t>"Encontré el sistema innecesariamente complejo"</a:t>
+            </a:r>
+            <a:r>
+              <a:rPr sz="1300" b="0" i="0">
+                <a:solidFill>
+                  <a:srgbClr val="52514E"/>
+                </a:solidFill>
+                <a:latin typeface="Segoe UI"/>
+              </a:rPr>
+              <a:t> (par, negativa).</a:t>
+            </a:r>
+          </a:p>
+        </p:txBody>
+      </p:sp>
+      <p:sp>
+        <p:nvSpPr>
+          <p:cNvPr id="8" name="TextBox 7"/>
+          <p:cNvSpPr txBox="1"/>
+          <p:nvPr/>
+        </p:nvSpPr>
+        <p:spPr>
+          <a:xfrm>
+            <a:off x="548640" y="2560320"/>
             <a:ext cx="4206240" cy="365760"/>
           </a:xfrm>
           <a:prstGeom prst="rect">
@@ -13979,13 +14109,13 @@
       </p:sp>
       <p:sp>
         <p:nvSpPr>
-          <p:cNvPr id="7" name="Oval 6"/>
+          <p:cNvPr id="9" name="Oval 8"/>
           <p:cNvSpPr/>
           <p:nvPr/>
         </p:nvSpPr>
         <p:spPr>
           <a:xfrm>
-            <a:off x="557784" y="2112264"/>
+            <a:off x="557784" y="3026664"/>
             <a:ext cx="347472" cy="347472"/>
           </a:xfrm>
           <a:prstGeom prst="ellipse">
@@ -14025,13 +14155,13 @@
       </p:sp>
       <p:sp>
         <p:nvSpPr>
-          <p:cNvPr id="8" name="TextBox 7"/>
-          <p:cNvSpPr txBox="1"/>
-          <p:nvPr/>
-        </p:nvSpPr>
-        <p:spPr>
-          <a:xfrm>
-            <a:off x="557784" y="2157984"/>
+          <p:cNvPr id="10" name="TextBox 9"/>
+          <p:cNvSpPr txBox="1"/>
+          <p:nvPr/>
+        </p:nvSpPr>
+        <p:spPr>
+          <a:xfrm>
+            <a:off x="557784" y="3072384"/>
             <a:ext cx="347472" cy="274320"/>
           </a:xfrm>
           <a:prstGeom prst="rect">
@@ -14064,13 +14194,13 @@
       </p:sp>
       <p:sp>
         <p:nvSpPr>
-          <p:cNvPr id="9" name="TextBox 8"/>
-          <p:cNvSpPr txBox="1"/>
-          <p:nvPr/>
-        </p:nvSpPr>
-        <p:spPr>
-          <a:xfrm>
-            <a:off x="1097280" y="2139696"/>
+          <p:cNvPr id="11" name="TextBox 10"/>
+          <p:cNvSpPr txBox="1"/>
+          <p:nvPr/>
+        </p:nvSpPr>
+        <p:spPr>
+          <a:xfrm>
+            <a:off x="1097280" y="3054096"/>
             <a:ext cx="3840480" cy="548640"/>
           </a:xfrm>
           <a:prstGeom prst="rect">
@@ -14112,13 +14242,13 @@
       </p:sp>
       <p:sp>
         <p:nvSpPr>
-          <p:cNvPr id="10" name="Oval 9"/>
+          <p:cNvPr id="12" name="Oval 11"/>
           <p:cNvSpPr/>
           <p:nvPr/>
         </p:nvSpPr>
         <p:spPr>
           <a:xfrm>
-            <a:off x="557784" y="2798064"/>
+            <a:off x="557784" y="3666744"/>
             <a:ext cx="347472" cy="347472"/>
           </a:xfrm>
           <a:prstGeom prst="ellipse">
@@ -14158,13 +14288,13 @@
       </p:sp>
       <p:sp>
         <p:nvSpPr>
-          <p:cNvPr id="11" name="TextBox 10"/>
-          <p:cNvSpPr txBox="1"/>
-          <p:nvPr/>
-        </p:nvSpPr>
-        <p:spPr>
-          <a:xfrm>
-            <a:off x="557784" y="2843784"/>
+          <p:cNvPr id="13" name="TextBox 12"/>
+          <p:cNvSpPr txBox="1"/>
+          <p:nvPr/>
+        </p:nvSpPr>
+        <p:spPr>
+          <a:xfrm>
+            <a:off x="557784" y="3712463"/>
             <a:ext cx="347472" cy="274320"/>
           </a:xfrm>
           <a:prstGeom prst="rect">
@@ -14197,13 +14327,13 @@
       </p:sp>
       <p:sp>
         <p:nvSpPr>
-          <p:cNvPr id="12" name="TextBox 11"/>
-          <p:cNvSpPr txBox="1"/>
-          <p:nvPr/>
-        </p:nvSpPr>
-        <p:spPr>
-          <a:xfrm>
-            <a:off x="1097280" y="2825496"/>
+          <p:cNvPr id="14" name="TextBox 13"/>
+          <p:cNvSpPr txBox="1"/>
+          <p:nvPr/>
+        </p:nvSpPr>
+        <p:spPr>
+          <a:xfrm>
+            <a:off x="1097280" y="3694176"/>
             <a:ext cx="3840480" cy="548640"/>
           </a:xfrm>
           <a:prstGeom prst="rect">
@@ -14245,13 +14375,13 @@
       </p:sp>
       <p:sp>
         <p:nvSpPr>
-          <p:cNvPr id="13" name="Oval 12"/>
+          <p:cNvPr id="15" name="Oval 14"/>
           <p:cNvSpPr/>
           <p:nvPr/>
         </p:nvSpPr>
         <p:spPr>
           <a:xfrm>
-            <a:off x="557784" y="3483864"/>
+            <a:off x="557784" y="4306823"/>
             <a:ext cx="347472" cy="347472"/>
           </a:xfrm>
           <a:prstGeom prst="ellipse">
@@ -14291,13 +14421,13 @@
       </p:sp>
       <p:sp>
         <p:nvSpPr>
-          <p:cNvPr id="14" name="TextBox 13"/>
-          <p:cNvSpPr txBox="1"/>
-          <p:nvPr/>
-        </p:nvSpPr>
-        <p:spPr>
-          <a:xfrm>
-            <a:off x="557784" y="3529584"/>
+          <p:cNvPr id="16" name="TextBox 15"/>
+          <p:cNvSpPr txBox="1"/>
+          <p:nvPr/>
+        </p:nvSpPr>
+        <p:spPr>
+          <a:xfrm>
+            <a:off x="557784" y="4352543"/>
             <a:ext cx="347472" cy="274320"/>
           </a:xfrm>
           <a:prstGeom prst="rect">
@@ -14330,13 +14460,13 @@
       </p:sp>
       <p:sp>
         <p:nvSpPr>
-          <p:cNvPr id="15" name="TextBox 14"/>
-          <p:cNvSpPr txBox="1"/>
-          <p:nvPr/>
-        </p:nvSpPr>
-        <p:spPr>
-          <a:xfrm>
-            <a:off x="1097280" y="3511296"/>
+          <p:cNvPr id="17" name="TextBox 16"/>
+          <p:cNvSpPr txBox="1"/>
+          <p:nvPr/>
+        </p:nvSpPr>
+        <p:spPr>
+          <a:xfrm>
+            <a:off x="1097280" y="4334255"/>
             <a:ext cx="3840480" cy="548640"/>
           </a:xfrm>
           <a:prstGeom prst="rect">
@@ -14378,13 +14508,13 @@
       </p:sp>
       <p:sp>
         <p:nvSpPr>
-          <p:cNvPr id="16" name="TextBox 15"/>
-          <p:cNvSpPr txBox="1"/>
-          <p:nvPr/>
-        </p:nvSpPr>
-        <p:spPr>
-          <a:xfrm>
-            <a:off x="548640" y="4251960"/>
+          <p:cNvPr id="18" name="TextBox 17"/>
+          <p:cNvSpPr txBox="1"/>
+          <p:nvPr/>
+        </p:nvSpPr>
+        <p:spPr>
+          <a:xfrm>
+            <a:off x="548640" y="5074920"/>
             <a:ext cx="4114800" cy="1097280"/>
           </a:xfrm>
           <a:prstGeom prst="rect">
@@ -14417,13 +14547,13 @@
       </p:sp>
       <p:sp>
         <p:nvSpPr>
-          <p:cNvPr id="17" name="Rectangle 16"/>
+          <p:cNvPr id="19" name="Rectangle 18"/>
           <p:cNvSpPr/>
           <p:nvPr/>
         </p:nvSpPr>
         <p:spPr>
           <a:xfrm>
-            <a:off x="5303520" y="2377440"/>
+            <a:off x="5303520" y="3291840"/>
             <a:ext cx="3190341" cy="914400"/>
           </a:xfrm>
           <a:prstGeom prst="rect">
@@ -14461,13 +14591,13 @@
       </p:sp>
       <p:sp>
         <p:nvSpPr>
-          <p:cNvPr id="18" name="TextBox 17"/>
-          <p:cNvSpPr txBox="1"/>
-          <p:nvPr/>
-        </p:nvSpPr>
-        <p:spPr>
-          <a:xfrm>
-            <a:off x="5303520" y="2670048"/>
+          <p:cNvPr id="20" name="TextBox 19"/>
+          <p:cNvSpPr txBox="1"/>
+          <p:nvPr/>
+        </p:nvSpPr>
+        <p:spPr>
+          <a:xfrm>
+            <a:off x="5303520" y="3584448"/>
             <a:ext cx="3217773" cy="365760"/>
           </a:xfrm>
           <a:prstGeom prst="rect">
@@ -14500,13 +14630,13 @@
       </p:sp>
       <p:sp>
         <p:nvSpPr>
-          <p:cNvPr id="19" name="Rectangle 18"/>
+          <p:cNvPr id="21" name="Rectangle 20"/>
           <p:cNvSpPr/>
           <p:nvPr/>
         </p:nvSpPr>
         <p:spPr>
           <a:xfrm>
-            <a:off x="8521293" y="2377440"/>
+            <a:off x="8521293" y="3291840"/>
             <a:ext cx="1045159" cy="914400"/>
           </a:xfrm>
           <a:prstGeom prst="rect">
@@ -14544,13 +14674,13 @@
       </p:sp>
       <p:sp>
         <p:nvSpPr>
-          <p:cNvPr id="20" name="TextBox 19"/>
-          <p:cNvSpPr txBox="1"/>
-          <p:nvPr/>
-        </p:nvSpPr>
-        <p:spPr>
-          <a:xfrm>
-            <a:off x="8521293" y="2670048"/>
+          <p:cNvPr id="22" name="TextBox 21"/>
+          <p:cNvSpPr txBox="1"/>
+          <p:nvPr/>
+        </p:nvSpPr>
+        <p:spPr>
+          <a:xfrm>
+            <a:off x="8521293" y="3584448"/>
             <a:ext cx="1072591" cy="365760"/>
           </a:xfrm>
           <a:prstGeom prst="rect">
@@ -14583,13 +14713,13 @@
       </p:sp>
       <p:sp>
         <p:nvSpPr>
-          <p:cNvPr id="21" name="Rectangle 20"/>
+          <p:cNvPr id="23" name="Rectangle 22"/>
           <p:cNvSpPr/>
           <p:nvPr/>
         </p:nvSpPr>
         <p:spPr>
           <a:xfrm>
-            <a:off x="9593884" y="2377440"/>
+            <a:off x="9593884" y="3291840"/>
             <a:ext cx="748619" cy="914400"/>
           </a:xfrm>
           <a:prstGeom prst="rect">
@@ -14627,13 +14757,13 @@
       </p:sp>
       <p:sp>
         <p:nvSpPr>
-          <p:cNvPr id="22" name="TextBox 21"/>
-          <p:cNvSpPr txBox="1"/>
-          <p:nvPr/>
-        </p:nvSpPr>
-        <p:spPr>
-          <a:xfrm>
-            <a:off x="9593884" y="2670048"/>
+          <p:cNvPr id="24" name="TextBox 23"/>
+          <p:cNvSpPr txBox="1"/>
+          <p:nvPr/>
+        </p:nvSpPr>
+        <p:spPr>
+          <a:xfrm>
+            <a:off x="9593884" y="3584448"/>
             <a:ext cx="776051" cy="365760"/>
           </a:xfrm>
           <a:prstGeom prst="rect">
@@ -14666,13 +14796,13 @@
       </p:sp>
       <p:sp>
         <p:nvSpPr>
-          <p:cNvPr id="23" name="Rectangle 22"/>
+          <p:cNvPr id="25" name="Rectangle 24"/>
           <p:cNvSpPr/>
           <p:nvPr/>
         </p:nvSpPr>
         <p:spPr>
           <a:xfrm>
-            <a:off x="10369936" y="2377440"/>
+            <a:off x="10369936" y="3291840"/>
             <a:ext cx="1215511" cy="914400"/>
           </a:xfrm>
           <a:prstGeom prst="rect">
@@ -14710,13 +14840,13 @@
       </p:sp>
       <p:sp>
         <p:nvSpPr>
-          <p:cNvPr id="24" name="TextBox 23"/>
-          <p:cNvSpPr txBox="1"/>
-          <p:nvPr/>
-        </p:nvSpPr>
-        <p:spPr>
-          <a:xfrm>
-            <a:off x="10369936" y="2670048"/>
+          <p:cNvPr id="26" name="TextBox 25"/>
+          <p:cNvSpPr txBox="1"/>
+          <p:nvPr/>
+        </p:nvSpPr>
+        <p:spPr>
+          <a:xfrm>
+            <a:off x="10369936" y="3584448"/>
             <a:ext cx="1242943" cy="365760"/>
           </a:xfrm>
           <a:prstGeom prst="rect">
@@ -14749,13 +14879,13 @@
       </p:sp>
       <p:sp>
         <p:nvSpPr>
-          <p:cNvPr id="25" name="TextBox 24"/>
-          <p:cNvSpPr txBox="1"/>
-          <p:nvPr/>
-        </p:nvSpPr>
-        <p:spPr>
-          <a:xfrm>
-            <a:off x="4846320" y="3383280"/>
+          <p:cNvPr id="27" name="TextBox 26"/>
+          <p:cNvSpPr txBox="1"/>
+          <p:nvPr/>
+        </p:nvSpPr>
+        <p:spPr>
+          <a:xfrm>
+            <a:off x="4846320" y="4297680"/>
             <a:ext cx="914400" cy="274320"/>
           </a:xfrm>
           <a:prstGeom prst="rect">
@@ -14788,13 +14918,13 @@
       </p:sp>
       <p:sp>
         <p:nvSpPr>
-          <p:cNvPr id="26" name="TextBox 25"/>
-          <p:cNvSpPr txBox="1"/>
-          <p:nvPr/>
-        </p:nvSpPr>
-        <p:spPr>
-          <a:xfrm>
-            <a:off x="8064093" y="3383280"/>
+          <p:cNvPr id="28" name="TextBox 27"/>
+          <p:cNvSpPr txBox="1"/>
+          <p:nvPr/>
+        </p:nvSpPr>
+        <p:spPr>
+          <a:xfrm>
+            <a:off x="8064093" y="4297680"/>
             <a:ext cx="914400" cy="274320"/>
           </a:xfrm>
           <a:prstGeom prst="rect">
@@ -14827,13 +14957,13 @@
       </p:sp>
       <p:sp>
         <p:nvSpPr>
-          <p:cNvPr id="27" name="TextBox 26"/>
-          <p:cNvSpPr txBox="1"/>
-          <p:nvPr/>
-        </p:nvSpPr>
-        <p:spPr>
-          <a:xfrm>
-            <a:off x="9136684" y="3383280"/>
+          <p:cNvPr id="29" name="TextBox 28"/>
+          <p:cNvSpPr txBox="1"/>
+          <p:nvPr/>
+        </p:nvSpPr>
+        <p:spPr>
+          <a:xfrm>
+            <a:off x="9136684" y="4297680"/>
             <a:ext cx="914400" cy="274320"/>
           </a:xfrm>
           <a:prstGeom prst="rect">
@@ -14866,13 +14996,13 @@
       </p:sp>
       <p:sp>
         <p:nvSpPr>
-          <p:cNvPr id="28" name="TextBox 27"/>
-          <p:cNvSpPr txBox="1"/>
-          <p:nvPr/>
-        </p:nvSpPr>
-        <p:spPr>
-          <a:xfrm>
-            <a:off x="9912736" y="3383280"/>
+          <p:cNvPr id="30" name="TextBox 29"/>
+          <p:cNvSpPr txBox="1"/>
+          <p:nvPr/>
+        </p:nvSpPr>
+        <p:spPr>
+          <a:xfrm>
+            <a:off x="9912736" y="4297680"/>
             <a:ext cx="914400" cy="274320"/>
           </a:xfrm>
           <a:prstGeom prst="rect">
@@ -14905,13 +15035,13 @@
       </p:sp>
       <p:sp>
         <p:nvSpPr>
-          <p:cNvPr id="29" name="TextBox 28"/>
-          <p:cNvSpPr txBox="1"/>
-          <p:nvPr/>
-        </p:nvSpPr>
-        <p:spPr>
-          <a:xfrm>
-            <a:off x="11155680" y="3383280"/>
+          <p:cNvPr id="31" name="TextBox 30"/>
+          <p:cNvSpPr txBox="1"/>
+          <p:nvPr/>
+        </p:nvSpPr>
+        <p:spPr>
+          <a:xfrm>
+            <a:off x="11155680" y="4297680"/>
             <a:ext cx="914400" cy="274320"/>
           </a:xfrm>
           <a:prstGeom prst="rect">
@@ -14944,13 +15074,13 @@
       </p:sp>
       <p:cxnSp>
         <p:nvCxnSpPr>
-          <p:cNvPr id="30" name="Connector 29"/>
+          <p:cNvPr id="32" name="Connector 31"/>
           <p:cNvCxnSpPr/>
           <p:nvPr/>
         </p:nvCxnSpPr>
         <p:spPr>
           <a:xfrm>
-            <a:off x="9593884" y="2057400"/>
+            <a:off x="9593884" y="2971800"/>
             <a:ext cx="0" cy="1234440"/>
           </a:xfrm>
           <a:prstGeom prst="line">
@@ -14979,13 +15109,13 @@
       </p:cxnSp>
       <p:sp>
         <p:nvSpPr>
-          <p:cNvPr id="31" name="TextBox 30"/>
-          <p:cNvSpPr txBox="1"/>
-          <p:nvPr/>
-        </p:nvSpPr>
-        <p:spPr>
-          <a:xfrm>
-            <a:off x="8130844" y="1691640"/>
+          <p:cNvPr id="33" name="TextBox 32"/>
+          <p:cNvSpPr txBox="1"/>
+          <p:nvPr/>
+        </p:nvSpPr>
+        <p:spPr>
+          <a:xfrm>
+            <a:off x="8130844" y="2606040"/>
             <a:ext cx="2926080" cy="320040"/>
           </a:xfrm>
           <a:prstGeom prst="rect">
@@ -15018,14 +15148,14 @@
       </p:sp>
       <p:sp>
         <p:nvSpPr>
-          <p:cNvPr id="32" name="TextBox 31"/>
-          <p:cNvSpPr txBox="1"/>
-          <p:nvPr/>
-        </p:nvSpPr>
-        <p:spPr>
-          <a:xfrm>
-            <a:off x="5303520" y="3886200"/>
-            <a:ext cx="6309360" cy="1463040"/>
+          <p:cNvPr id="34" name="TextBox 33"/>
+          <p:cNvSpPr txBox="1"/>
+          <p:nvPr/>
+        </p:nvSpPr>
+        <p:spPr>
+          <a:xfrm>
+            <a:off x="5303520" y="4754880"/>
+            <a:ext cx="6309360" cy="1097280"/>
           </a:xfrm>
           <a:prstGeom prst="rect">
             <a:avLst/>
@@ -15066,13 +15196,13 @@
       </p:sp>
       <p:sp>
         <p:nvSpPr>
-          <p:cNvPr id="33" name="TextBox 32"/>
-          <p:cNvSpPr txBox="1"/>
-          <p:nvPr/>
-        </p:nvSpPr>
-        <p:spPr>
-          <a:xfrm>
-            <a:off x="5303520" y="5257800"/>
+          <p:cNvPr id="35" name="TextBox 34"/>
+          <p:cNvSpPr txBox="1"/>
+          <p:nvPr/>
+        </p:nvSpPr>
+        <p:spPr>
+          <a:xfrm>
+            <a:off x="5303520" y="5897880"/>
             <a:ext cx="6309360" cy="365760"/>
           </a:xfrm>
           <a:prstGeom prst="rect">

</xml_diff>